<commit_message>
Regenerate AI Value Proposition deck with an AI Use Cases slide
Replace the previous AI Capabilities slide (RAG/Query Data/Query
Features/process strip) with a dedicated AI Use Cases slide: a "14"
stat card (9 Assistive / 5 Augmented) plus four concrete, plain-English
examples pulled straight from the actual 14-use-case catalog — spotting
why someone's stuck, coaching the coach, catching change overload
early, and reporting up in plain English. Keeps the deck at 3 slides
total as requested.

Co-Authored-By: Claude Sonnet 5 <noreply@anthropic.com>
Claude-Session: https://claude.ai/code/session_01Cm5htKGTSC5qKf9PgkxVGS
</commit_message>
<xml_diff>
--- a/deliverables/journi_AI_Value_Proposition.pptx
+++ b/deliverables/journi_AI_Value_Proposition.pptx
@@ -1254,7 +1254,7 @@
                 <a:ea typeface="Calibri" pitchFamily="34" charset="-122"/>
                 <a:cs typeface="Calibri" pitchFamily="34" charset="-120"/>
               </a:rPr>
-              <a:t>Change programs fail for human reasons, not technical ones — yet most organizations instrument the go-live and never the people. journi gives Change Managers, sponsors, and executives one governed platform to measure readiness, diagnose resistance, and prove adoption — start to finish, scoped to exactly what each role should see.</a:t>
+              <a:t>Change programs fail for human reasons, not technical ones — yet most organizations instrument the go-live and never the people. journi gives Change Managers, sponsors, and executives one governed, AI-assisted platform to measure readiness, diagnose resistance, and prove adoption — start to finish, scoped to exactly what each role should see.</a:t>
             </a:r>
             <a:endParaRPr lang="en-US" sz="1600" dirty="0"/>
           </a:p>
@@ -1769,7 +1769,7 @@
                 <a:ea typeface="Calibri" pitchFamily="34" charset="-122"/>
                 <a:cs typeface="Calibri" pitchFamily="34" charset="-120"/>
               </a:rPr>
-              <a:t>AI CAPABILITIES</a:t>
+              <a:t>AI USE CASES</a:t>
             </a:r>
             <a:endParaRPr lang="en-US" sz="1200" dirty="0"/>
           </a:p>
@@ -1800,7 +1800,7 @@
               <a:buNone/>
             </a:pPr>
             <a:r>
-              <a:rPr lang="en-US" sz="3000" b="1" dirty="0">
+              <a:rPr lang="en-US" sz="2700" b="1" dirty="0">
                 <a:solidFill>
                   <a:srgbClr val="3A3A3C"/>
                 </a:solidFill>
@@ -1808,9 +1808,9 @@
                 <a:ea typeface="Cambria" pitchFamily="34" charset="-122"/>
                 <a:cs typeface="Cambria" pitchFamily="34" charset="-120"/>
               </a:rPr>
-              <a:t>AI you can actually trust with your data</a:t>
-            </a:r>
-            <a:endParaRPr lang="en-US" sz="3000" dirty="0"/>
+              <a:t>Built for the moments Change Managers actually face</a:t>
+            </a:r>
+            <a:endParaRPr lang="en-US" sz="2700" dirty="0"/>
           </a:p>
         </p:txBody>
       </p:sp>
@@ -1822,7 +1822,7 @@
         </p:nvSpPr>
         <p:spPr>
           <a:xfrm>
-            <a:off x="548640" y="1261872"/>
+            <a:off x="548640" y="1280160"/>
             <a:ext cx="11064240" cy="365760"/>
           </a:xfrm>
           <a:prstGeom prst="rect">
@@ -1847,7 +1847,7 @@
                 <a:ea typeface="Calibri" pitchFamily="34" charset="-122"/>
                 <a:cs typeface="Calibri" pitchFamily="34" charset="-120"/>
               </a:rPr>
-              <a:t>Every suggestion is grounded in your own records — never invented, always reviewable.</a:t>
+              <a:t>Every use case is Assistive or Augmented — grounded in your own data, never autonomous.</a:t>
             </a:r>
             <a:endParaRPr lang="en-US" sz="1400" dirty="0"/>
           </a:p>
@@ -1861,12 +1861,12 @@
         </p:nvSpPr>
         <p:spPr>
           <a:xfrm>
-            <a:off x="548640" y="1783080"/>
-            <a:ext cx="5440680" cy="1691640"/>
+            <a:off x="548640" y="1828800"/>
+            <a:ext cx="3200400" cy="3611880"/>
           </a:xfrm>
           <a:prstGeom prst="roundRect">
             <a:avLst>
-              <a:gd name="adj" fmla="val 4324"/>
+              <a:gd name="adj" fmla="val 2286"/>
             </a:avLst>
           </a:prstGeom>
           <a:solidFill>
@@ -1895,7 +1895,7 @@
         </p:nvSpPr>
         <p:spPr>
           <a:xfrm>
-            <a:off x="777240" y="2011680"/>
+            <a:off x="868680" y="2148840"/>
             <a:ext cx="566928" cy="566928"/>
           </a:xfrm>
           <a:prstGeom prst="ellipse">
@@ -1909,7 +1909,7 @@
       </p:sp>
       <p:pic>
         <p:nvPicPr>
-          <p:cNvPr id="7" name="Image 0" descr="/tmp/pptx_assets/icon_ai_library.png">    </p:cNvPr>
+          <p:cNvPr id="7" name="Image 0" descr="/tmp/pptx_assets/icon_usecases_stack.png">    </p:cNvPr>
           <p:cNvPicPr>
             <a:picLocks noChangeAspect="1"/>
           </p:cNvPicPr>
@@ -1923,7 +1923,7 @@
         </p:blipFill>
         <p:spPr>
           <a:xfrm>
-            <a:off x="913303" y="2147743"/>
+            <a:off x="1004743" y="2284903"/>
             <a:ext cx="294803" cy="294803"/>
           </a:xfrm>
           <a:prstGeom prst="rect">
@@ -1939,8 +1939,8 @@
         </p:nvSpPr>
         <p:spPr>
           <a:xfrm>
-            <a:off x="1508760" y="1984248"/>
-            <a:ext cx="4251960" cy="320040"/>
+            <a:off x="777240" y="2880360"/>
+            <a:ext cx="2743200" cy="1005840"/>
           </a:xfrm>
           <a:prstGeom prst="rect">
             <a:avLst/>
@@ -1956,17 +1956,17 @@
               <a:buNone/>
             </a:pPr>
             <a:r>
-              <a:rPr lang="en-US" sz="1500" b="1" dirty="0">
-                <a:solidFill>
-                  <a:srgbClr val="3A3A3C"/>
+              <a:rPr lang="en-US" sz="7200" b="1" dirty="0">
+                <a:solidFill>
+                  <a:srgbClr val="E07B00"/>
                 </a:solidFill>
                 <a:latin typeface="Cambria" pitchFamily="34" charset="0"/>
                 <a:ea typeface="Cambria" pitchFamily="34" charset="-122"/>
                 <a:cs typeface="Cambria" pitchFamily="34" charset="-120"/>
               </a:rPr>
-              <a:t>AI Use Case Library</a:t>
-            </a:r>
-            <a:endParaRPr lang="en-US" sz="1500" dirty="0"/>
+              <a:t>14</a:t>
+            </a:r>
+            <a:endParaRPr lang="en-US" sz="7200" dirty="0"/>
           </a:p>
         </p:txBody>
       </p:sp>
@@ -1978,8 +1978,8 @@
         </p:nvSpPr>
         <p:spPr>
           <a:xfrm>
-            <a:off x="777240" y="2624328"/>
-            <a:ext cx="4983480" cy="731520"/>
+            <a:off x="822960" y="3886200"/>
+            <a:ext cx="2651760" cy="640080"/>
           </a:xfrm>
           <a:prstGeom prst="rect">
             <a:avLst/>
@@ -1993,22 +1993,22 @@
           <a:p>
             <a:pPr indent="0" marL="0">
               <a:lnSpc>
-                <a:spcPct val="115000"/>
+                <a:spcPct val="120000"/>
               </a:lnSpc>
               <a:buNone/>
             </a:pPr>
             <a:r>
-              <a:rPr lang="en-US" sz="1150" dirty="0">
-                <a:solidFill>
-                  <a:srgbClr val="58595B"/>
+              <a:rPr lang="en-US" sz="1400" dirty="0">
+                <a:solidFill>
+                  <a:srgbClr val="3A3A3C"/>
                 </a:solidFill>
                 <a:latin typeface="Calibri" pitchFamily="34" charset="0"/>
                 <a:ea typeface="Calibri" pitchFamily="34" charset="-122"/>
                 <a:cs typeface="Calibri" pitchFamily="34" charset="-120"/>
               </a:rPr>
-              <a:t>14 governed AI use cases embedded across the change lifecycle — from stakeholder-impact drafting to executive readiness narratives.</a:t>
-            </a:r>
-            <a:endParaRPr lang="en-US" sz="1150" dirty="0"/>
+              <a:t>AI use cases across the change lifecycle</a:t>
+            </a:r>
+            <a:endParaRPr lang="en-US" sz="1400" dirty="0"/>
           </a:p>
         </p:txBody>
       </p:sp>
@@ -2020,8 +2020,112 @@
         </p:nvSpPr>
         <p:spPr>
           <a:xfrm>
-            <a:off x="6263640" y="1783080"/>
-            <a:ext cx="5440680" cy="1691640"/>
+            <a:off x="822960" y="4572000"/>
+            <a:ext cx="2651760" cy="0"/>
+          </a:xfrm>
+          <a:prstGeom prst="line">
+            <a:avLst/>
+          </a:prstGeom>
+          <a:noFill/>
+          <a:ln w="12700">
+            <a:solidFill>
+              <a:srgbClr val="E3E3E4"/>
+            </a:solidFill>
+            <a:prstDash val="solid"/>
+          </a:ln>
+        </p:spPr>
+      </p:sp>
+      <p:sp>
+        <p:nvSpPr>
+          <p:cNvPr id="11" name="Text 8"/>
+          <p:cNvSpPr txBox="1"/>
+          <p:nvPr/>
+        </p:nvSpPr>
+        <p:spPr>
+          <a:xfrm>
+            <a:off x="822960" y="4709160"/>
+            <a:ext cx="2651760" cy="457200"/>
+          </a:xfrm>
+          <a:prstGeom prst="rect">
+            <a:avLst/>
+          </a:prstGeom>
+          <a:noFill/>
+          <a:ln/>
+        </p:spPr>
+        <p:txBody>
+          <a:bodyPr wrap="square" lIns="0" tIns="0" rIns="0" bIns="0" rtlCol="0" anchor="ctr"/>
+          <a:lstStyle/>
+          <a:p>
+            <a:pPr indent="0" marL="0">
+              <a:buNone/>
+            </a:pPr>
+            <a:r>
+              <a:rPr lang="en-US" sz="1300" b="1" dirty="0">
+                <a:solidFill>
+                  <a:srgbClr val="E07B00"/>
+                </a:solidFill>
+                <a:latin typeface="Calibri" pitchFamily="34" charset="0"/>
+                <a:ea typeface="Calibri" pitchFamily="34" charset="-122"/>
+                <a:cs typeface="Calibri" pitchFamily="34" charset="-120"/>
+              </a:rPr>
+              <a:t>9</a:t>
+            </a:r>
+            <a:pPr indent="0" marL="0">
+              <a:buNone/>
+            </a:pPr>
+            <a:r>
+              <a:rPr lang="en-US" sz="1300" dirty="0">
+                <a:solidFill>
+                  <a:srgbClr val="58595B"/>
+                </a:solidFill>
+                <a:latin typeface="Calibri" pitchFamily="34" charset="0"/>
+                <a:ea typeface="Calibri" pitchFamily="34" charset="-122"/>
+                <a:cs typeface="Calibri" pitchFamily="34" charset="-120"/>
+              </a:rPr>
+              <a:t> Assistive    </a:t>
+            </a:r>
+            <a:pPr indent="0" marL="0">
+              <a:buNone/>
+            </a:pPr>
+            <a:r>
+              <a:rPr lang="en-US" sz="1300" b="1" dirty="0">
+                <a:solidFill>
+                  <a:srgbClr val="E07B00"/>
+                </a:solidFill>
+                <a:latin typeface="Calibri" pitchFamily="34" charset="0"/>
+                <a:ea typeface="Calibri" pitchFamily="34" charset="-122"/>
+                <a:cs typeface="Calibri" pitchFamily="34" charset="-120"/>
+              </a:rPr>
+              <a:t>5</a:t>
+            </a:r>
+            <a:pPr indent="0" marL="0">
+              <a:buNone/>
+            </a:pPr>
+            <a:r>
+              <a:rPr lang="en-US" sz="1300" dirty="0">
+                <a:solidFill>
+                  <a:srgbClr val="58595B"/>
+                </a:solidFill>
+                <a:latin typeface="Calibri" pitchFamily="34" charset="0"/>
+                <a:ea typeface="Calibri" pitchFamily="34" charset="-122"/>
+                <a:cs typeface="Calibri" pitchFamily="34" charset="-120"/>
+              </a:rPr>
+              <a:t> Augmented</a:t>
+            </a:r>
+            <a:endParaRPr lang="en-US" sz="1300" dirty="0"/>
+          </a:p>
+        </p:txBody>
+      </p:sp>
+      <p:sp>
+        <p:nvSpPr>
+          <p:cNvPr id="12" name="Shape 9"/>
+          <p:cNvSpPr/>
+          <p:nvPr/>
+        </p:nvSpPr>
+        <p:spPr>
+          <a:xfrm>
+            <a:off x="4023360" y="1828800"/>
+            <a:ext cx="3694176" cy="1691640"/>
           </a:xfrm>
           <a:prstGeom prst="roundRect">
             <a:avLst>
@@ -2048,14 +2152,14 @@
       </p:sp>
       <p:sp>
         <p:nvSpPr>
-          <p:cNvPr id="11" name="Shape 8"/>
+          <p:cNvPr id="13" name="Shape 10"/>
           <p:cNvSpPr/>
           <p:nvPr/>
         </p:nvSpPr>
         <p:spPr>
           <a:xfrm>
-            <a:off x="6492240" y="2011680"/>
-            <a:ext cx="566928" cy="566928"/>
+            <a:off x="4224528" y="2029968"/>
+            <a:ext cx="457200" cy="457200"/>
           </a:xfrm>
           <a:prstGeom prst="ellipse">
             <a:avLst/>
@@ -2068,7 +2172,7 @@
       </p:sp>
       <p:pic>
         <p:nvPicPr>
-          <p:cNvPr id="12" name="Image 1" descr="/tmp/pptx_assets/icon_rag.png">    </p:cNvPr>
+          <p:cNvPr id="14" name="Image 1" descr="/tmp/pptx_assets/icon_barrier.png">    </p:cNvPr>
           <p:cNvPicPr>
             <a:picLocks noChangeAspect="1"/>
           </p:cNvPicPr>
@@ -2082,8 +2186,8 @@
         </p:blipFill>
         <p:spPr>
           <a:xfrm>
-            <a:off x="6628303" y="2147743"/>
-            <a:ext cx="294803" cy="294803"/>
+            <a:off x="4334256" y="2139696"/>
+            <a:ext cx="237744" cy="237744"/>
           </a:xfrm>
           <a:prstGeom prst="rect">
             <a:avLst/>
@@ -2092,14 +2196,14 @@
       </p:pic>
       <p:sp>
         <p:nvSpPr>
-          <p:cNvPr id="13" name="Text 9"/>
-          <p:cNvSpPr txBox="1"/>
-          <p:nvPr/>
-        </p:nvSpPr>
-        <p:spPr>
-          <a:xfrm>
-            <a:off x="7223760" y="1984248"/>
-            <a:ext cx="4251960" cy="320040"/>
+          <p:cNvPr id="15" name="Text 11"/>
+          <p:cNvSpPr txBox="1"/>
+          <p:nvPr/>
+        </p:nvSpPr>
+        <p:spPr>
+          <a:xfrm>
+            <a:off x="4800600" y="2011680"/>
+            <a:ext cx="2734056" cy="502920"/>
           </a:xfrm>
           <a:prstGeom prst="rect">
             <a:avLst/>
@@ -2115,7 +2219,7 @@
               <a:buNone/>
             </a:pPr>
             <a:r>
-              <a:rPr lang="en-US" sz="1500" b="1" dirty="0">
+              <a:rPr lang="en-US" sz="1400" b="1" dirty="0">
                 <a:solidFill>
                   <a:srgbClr val="3A3A3C"/>
                 </a:solidFill>
@@ -2123,22 +2227,22 @@
                 <a:ea typeface="Cambria" pitchFamily="34" charset="-122"/>
                 <a:cs typeface="Cambria" pitchFamily="34" charset="-120"/>
               </a:rPr>
-              <a:t>RAG-Grounded Generation</a:t>
-            </a:r>
-            <a:endParaRPr lang="en-US" sz="1500" dirty="0"/>
-          </a:p>
-        </p:txBody>
-      </p:sp>
-      <p:sp>
-        <p:nvSpPr>
-          <p:cNvPr id="14" name="Text 10"/>
-          <p:cNvSpPr txBox="1"/>
-          <p:nvPr/>
-        </p:nvSpPr>
-        <p:spPr>
-          <a:xfrm>
-            <a:off x="6492240" y="2624328"/>
-            <a:ext cx="4983480" cy="731520"/>
+              <a:t>Spot why someone’s stuck</a:t>
+            </a:r>
+            <a:endParaRPr lang="en-US" sz="1400" dirty="0"/>
+          </a:p>
+        </p:txBody>
+      </p:sp>
+      <p:sp>
+        <p:nvSpPr>
+          <p:cNvPr id="16" name="Text 12"/>
+          <p:cNvSpPr txBox="1"/>
+          <p:nvPr/>
+        </p:nvSpPr>
+        <p:spPr>
+          <a:xfrm>
+            <a:off x="4224528" y="2606040"/>
+            <a:ext cx="3291840" cy="795528"/>
           </a:xfrm>
           <a:prstGeom prst="rect">
             <a:avLst/>
@@ -2152,12 +2256,12 @@
           <a:p>
             <a:pPr indent="0" marL="0">
               <a:lnSpc>
-                <a:spcPct val="115000"/>
+                <a:spcPct val="112000"/>
               </a:lnSpc>
               <a:buNone/>
             </a:pPr>
             <a:r>
-              <a:rPr lang="en-US" sz="1150" dirty="0">
+              <a:rPr lang="en-US" sz="1080" dirty="0">
                 <a:solidFill>
                   <a:srgbClr val="58595B"/>
                 </a:solidFill>
@@ -2165,22 +2269,22 @@
                 <a:ea typeface="Calibri" pitchFamily="34" charset="-122"/>
                 <a:cs typeface="Calibri" pitchFamily="34" charset="-120"/>
               </a:rPr>
-              <a:t>Real retrieval, not guesswork — every generated answer pulls from journi’s own methodology and your live project data before a single word is written.</a:t>
-            </a:r>
-            <a:endParaRPr lang="en-US" sz="1150" dirty="0"/>
-          </a:p>
-        </p:txBody>
-      </p:sp>
-      <p:sp>
-        <p:nvSpPr>
-          <p:cNvPr id="15" name="Shape 11"/>
+              <a:t>Reads open-text survey answers and flags the likely reason — e.g. “fear of losing their role” — for a Change Manager to confirm.</a:t>
+            </a:r>
+            <a:endParaRPr lang="en-US" sz="1080" dirty="0"/>
+          </a:p>
+        </p:txBody>
+      </p:sp>
+      <p:sp>
+        <p:nvSpPr>
+          <p:cNvPr id="17" name="Shape 13"/>
           <p:cNvSpPr/>
           <p:nvPr/>
         </p:nvSpPr>
         <p:spPr>
           <a:xfrm>
-            <a:off x="548640" y="3703320"/>
-            <a:ext cx="5440680" cy="1691640"/>
+            <a:off x="7946136" y="1828800"/>
+            <a:ext cx="3694176" cy="1691640"/>
           </a:xfrm>
           <a:prstGeom prst="roundRect">
             <a:avLst>
@@ -2207,27 +2311,27 @@
       </p:sp>
       <p:sp>
         <p:nvSpPr>
-          <p:cNvPr id="16" name="Shape 12"/>
+          <p:cNvPr id="18" name="Shape 14"/>
           <p:cNvSpPr/>
           <p:nvPr/>
         </p:nvSpPr>
         <p:spPr>
           <a:xfrm>
-            <a:off x="777240" y="3931920"/>
-            <a:ext cx="566928" cy="566928"/>
+            <a:off x="8147304" y="2029968"/>
+            <a:ext cx="457200" cy="457200"/>
           </a:xfrm>
           <a:prstGeom prst="ellipse">
             <a:avLst/>
           </a:prstGeom>
           <a:solidFill>
-            <a:srgbClr val="58595B"/>
+            <a:srgbClr val="F8931D"/>
           </a:solidFill>
           <a:ln/>
         </p:spPr>
       </p:sp>
       <p:pic>
         <p:nvPicPr>
-          <p:cNvPr id="17" name="Image 2" descr="/tmp/pptx_assets/icon_query_data.png">    </p:cNvPr>
+          <p:cNvPr id="19" name="Image 2" descr="/tmp/pptx_assets/icon_coaching.png">    </p:cNvPr>
           <p:cNvPicPr>
             <a:picLocks noChangeAspect="1"/>
           </p:cNvPicPr>
@@ -2241,8 +2345,8 @@
         </p:blipFill>
         <p:spPr>
           <a:xfrm>
-            <a:off x="913303" y="4067983"/>
-            <a:ext cx="294803" cy="294803"/>
+            <a:off x="8257032" y="2139696"/>
+            <a:ext cx="237744" cy="237744"/>
           </a:xfrm>
           <a:prstGeom prst="rect">
             <a:avLst/>
@@ -2251,14 +2355,14 @@
       </p:pic>
       <p:sp>
         <p:nvSpPr>
-          <p:cNvPr id="18" name="Text 13"/>
-          <p:cNvSpPr txBox="1"/>
-          <p:nvPr/>
-        </p:nvSpPr>
-        <p:spPr>
-          <a:xfrm>
-            <a:off x="1508760" y="3904488"/>
-            <a:ext cx="4251960" cy="320040"/>
+          <p:cNvPr id="20" name="Text 15"/>
+          <p:cNvSpPr txBox="1"/>
+          <p:nvPr/>
+        </p:nvSpPr>
+        <p:spPr>
+          <a:xfrm>
+            <a:off x="8723376" y="2011680"/>
+            <a:ext cx="2734056" cy="502920"/>
           </a:xfrm>
           <a:prstGeom prst="rect">
             <a:avLst/>
@@ -2274,7 +2378,7 @@
               <a:buNone/>
             </a:pPr>
             <a:r>
-              <a:rPr lang="en-US" sz="1500" b="1" dirty="0">
+              <a:rPr lang="en-US" sz="1400" b="1" dirty="0">
                 <a:solidFill>
                   <a:srgbClr val="3A3A3C"/>
                 </a:solidFill>
@@ -2282,22 +2386,22 @@
                 <a:ea typeface="Cambria" pitchFamily="34" charset="-122"/>
                 <a:cs typeface="Cambria" pitchFamily="34" charset="-120"/>
               </a:rPr>
-              <a:t>Query Data</a:t>
-            </a:r>
-            <a:endParaRPr lang="en-US" sz="1500" dirty="0"/>
-          </a:p>
-        </p:txBody>
-      </p:sp>
-      <p:sp>
-        <p:nvSpPr>
-          <p:cNvPr id="19" name="Text 14"/>
-          <p:cNvSpPr txBox="1"/>
-          <p:nvPr/>
-        </p:nvSpPr>
-        <p:spPr>
-          <a:xfrm>
-            <a:off x="777240" y="4544568"/>
-            <a:ext cx="4983480" cy="731520"/>
+              <a:t>Coach the coach</a:t>
+            </a:r>
+            <a:endParaRPr lang="en-US" sz="1400" dirty="0"/>
+          </a:p>
+        </p:txBody>
+      </p:sp>
+      <p:sp>
+        <p:nvSpPr>
+          <p:cNvPr id="21" name="Text 16"/>
+          <p:cNvSpPr txBox="1"/>
+          <p:nvPr/>
+        </p:nvSpPr>
+        <p:spPr>
+          <a:xfrm>
+            <a:off x="8147304" y="2606040"/>
+            <a:ext cx="3291840" cy="795528"/>
           </a:xfrm>
           <a:prstGeom prst="rect">
             <a:avLst/>
@@ -2311,12 +2415,12 @@
           <a:p>
             <a:pPr indent="0" marL="0">
               <a:lnSpc>
-                <a:spcPct val="115000"/>
+                <a:spcPct val="112000"/>
               </a:lnSpc>
               <a:buNone/>
             </a:pPr>
             <a:r>
-              <a:rPr lang="en-US" sz="1150" dirty="0">
+              <a:rPr lang="en-US" sz="1080" dirty="0">
                 <a:solidFill>
                   <a:srgbClr val="58595B"/>
                 </a:solidFill>
@@ -2324,22 +2428,22 @@
                 <a:ea typeface="Calibri" pitchFamily="34" charset="-122"/>
                 <a:cs typeface="Calibri" pitchFamily="34" charset="-120"/>
               </a:rPr>
-              <a:t>“How many active projects?” Ask a plain-language question about your own portfolio and get an exact, RBAC-scoped answer — computed, not hallucinated.</a:t>
-            </a:r>
-            <a:endParaRPr lang="en-US" sz="1150" dirty="0"/>
-          </a:p>
-        </p:txBody>
-      </p:sp>
-      <p:sp>
-        <p:nvSpPr>
-          <p:cNvPr id="20" name="Shape 15"/>
+              <a:t>Turns a flagged team barrier into a ready-to-use coaching conversation, tailored for that manager and that team.</a:t>
+            </a:r>
+            <a:endParaRPr lang="en-US" sz="1080" dirty="0"/>
+          </a:p>
+        </p:txBody>
+      </p:sp>
+      <p:sp>
+        <p:nvSpPr>
+          <p:cNvPr id="22" name="Shape 17"/>
           <p:cNvSpPr/>
           <p:nvPr/>
         </p:nvSpPr>
         <p:spPr>
           <a:xfrm>
-            <a:off x="6263640" y="3703320"/>
-            <a:ext cx="5440680" cy="1691640"/>
+            <a:off x="4023360" y="3749040"/>
+            <a:ext cx="3694176" cy="1691640"/>
           </a:xfrm>
           <a:prstGeom prst="roundRect">
             <a:avLst>
@@ -2366,14 +2470,14 @@
       </p:sp>
       <p:sp>
         <p:nvSpPr>
-          <p:cNvPr id="21" name="Shape 16"/>
+          <p:cNvPr id="23" name="Shape 18"/>
           <p:cNvSpPr/>
           <p:nvPr/>
         </p:nvSpPr>
         <p:spPr>
           <a:xfrm>
-            <a:off x="6492240" y="3931920"/>
-            <a:ext cx="566928" cy="566928"/>
+            <a:off x="4224528" y="3950208"/>
+            <a:ext cx="457200" cy="457200"/>
           </a:xfrm>
           <a:prstGeom prst="ellipse">
             <a:avLst/>
@@ -2386,7 +2490,7 @@
       </p:sp>
       <p:pic>
         <p:nvPicPr>
-          <p:cNvPr id="22" name="Image 3" descr="/tmp/pptx_assets/icon_query_features.png">    </p:cNvPr>
+          <p:cNvPr id="24" name="Image 3" descr="/tmp/pptx_assets/icon_saturation.png">    </p:cNvPr>
           <p:cNvPicPr>
             <a:picLocks noChangeAspect="1"/>
           </p:cNvPicPr>
@@ -2400,8 +2504,8 @@
         </p:blipFill>
         <p:spPr>
           <a:xfrm>
-            <a:off x="6628303" y="4067983"/>
-            <a:ext cx="294803" cy="294803"/>
+            <a:off x="4334256" y="4059936"/>
+            <a:ext cx="237744" cy="237744"/>
           </a:xfrm>
           <a:prstGeom prst="rect">
             <a:avLst/>
@@ -2410,14 +2514,14 @@
       </p:pic>
       <p:sp>
         <p:nvSpPr>
-          <p:cNvPr id="23" name="Text 17"/>
-          <p:cNvSpPr txBox="1"/>
-          <p:nvPr/>
-        </p:nvSpPr>
-        <p:spPr>
-          <a:xfrm>
-            <a:off x="7223760" y="3904488"/>
-            <a:ext cx="4251960" cy="320040"/>
+          <p:cNvPr id="25" name="Text 19"/>
+          <p:cNvSpPr txBox="1"/>
+          <p:nvPr/>
+        </p:nvSpPr>
+        <p:spPr>
+          <a:xfrm>
+            <a:off x="4800600" y="3931920"/>
+            <a:ext cx="2734056" cy="502920"/>
           </a:xfrm>
           <a:prstGeom prst="rect">
             <a:avLst/>
@@ -2433,7 +2537,7 @@
               <a:buNone/>
             </a:pPr>
             <a:r>
-              <a:rPr lang="en-US" sz="1500" b="1" dirty="0">
+              <a:rPr lang="en-US" sz="1400" b="1" dirty="0">
                 <a:solidFill>
                   <a:srgbClr val="3A3A3C"/>
                 </a:solidFill>
@@ -2441,22 +2545,22 @@
                 <a:ea typeface="Cambria" pitchFamily="34" charset="-122"/>
                 <a:cs typeface="Cambria" pitchFamily="34" charset="-120"/>
               </a:rPr>
-              <a:t>Query Features</a:t>
-            </a:r>
-            <a:endParaRPr lang="en-US" sz="1500" dirty="0"/>
-          </a:p>
-        </p:txBody>
-      </p:sp>
-      <p:sp>
-        <p:nvSpPr>
-          <p:cNvPr id="24" name="Text 18"/>
-          <p:cNvSpPr txBox="1"/>
-          <p:nvPr/>
-        </p:nvSpPr>
-        <p:spPr>
-          <a:xfrm>
-            <a:off x="6492240" y="4544568"/>
-            <a:ext cx="4983480" cy="731520"/>
+              <a:t>Catch change overload early</a:t>
+            </a:r>
+            <a:endParaRPr lang="en-US" sz="1400" dirty="0"/>
+          </a:p>
+        </p:txBody>
+      </p:sp>
+      <p:sp>
+        <p:nvSpPr>
+          <p:cNvPr id="26" name="Text 20"/>
+          <p:cNvSpPr txBox="1"/>
+          <p:nvPr/>
+        </p:nvSpPr>
+        <p:spPr>
+          <a:xfrm>
+            <a:off x="4224528" y="4526280"/>
+            <a:ext cx="3291840" cy="795528"/>
           </a:xfrm>
           <a:prstGeom prst="rect">
             <a:avLst/>
@@ -2470,12 +2574,12 @@
           <a:p>
             <a:pPr indent="0" marL="0">
               <a:lnSpc>
-                <a:spcPct val="115000"/>
+                <a:spcPct val="112000"/>
               </a:lnSpc>
               <a:buNone/>
             </a:pPr>
             <a:r>
-              <a:rPr lang="en-US" sz="1150" dirty="0">
+              <a:rPr lang="en-US" sz="1080" dirty="0">
                 <a:solidFill>
                   <a:srgbClr val="58595B"/>
                 </a:solidFill>
@@ -2483,571 +2587,69 @@
                 <a:ea typeface="Calibri" pitchFamily="34" charset="-122"/>
                 <a:cs typeface="Calibri" pitchFamily="34" charset="-120"/>
               </a:rPr>
-              <a:t>Ask what journi can do, and get routed straight to the right module — a built-in guide that already knows your role.</a:t>
-            </a:r>
-            <a:endParaRPr lang="en-US" sz="1150" dirty="0"/>
-          </a:p>
-        </p:txBody>
-      </p:sp>
-      <p:sp>
-        <p:nvSpPr>
-          <p:cNvPr id="25" name="Text 19"/>
-          <p:cNvSpPr txBox="1"/>
-          <p:nvPr/>
-        </p:nvSpPr>
-        <p:spPr>
-          <a:xfrm>
-            <a:off x="548640" y="5440680"/>
-            <a:ext cx="3657600" cy="256032"/>
-          </a:xfrm>
-          <a:prstGeom prst="rect">
-            <a:avLst/>
-          </a:prstGeom>
-          <a:noFill/>
-          <a:ln/>
-        </p:spPr>
-        <p:txBody>
-          <a:bodyPr wrap="square" lIns="0" tIns="0" rIns="0" bIns="0" rtlCol="0" anchor="ctr"/>
-          <a:lstStyle/>
-          <a:p>
-            <a:pPr indent="0" marL="0">
-              <a:buNone/>
-            </a:pPr>
-            <a:r>
-              <a:rPr lang="en-US" sz="1050" b="1" spc="150" kern="0" dirty="0">
-                <a:solidFill>
-                  <a:srgbClr val="808184"/>
-                </a:solidFill>
-                <a:latin typeface="Calibri" pitchFamily="34" charset="0"/>
-                <a:ea typeface="Calibri" pitchFamily="34" charset="-122"/>
-                <a:cs typeface="Calibri" pitchFamily="34" charset="-120"/>
-              </a:rPr>
-              <a:t>HOW IT WORKS</a:t>
-            </a:r>
-            <a:endParaRPr lang="en-US" sz="1050" dirty="0"/>
-          </a:p>
-        </p:txBody>
-      </p:sp>
-      <p:sp>
-        <p:nvSpPr>
-          <p:cNvPr id="26" name="Shape 20"/>
+              <a:t>Warns when too many changes are about to hit the same population at once, and suggests a better rollout window.</a:t>
+            </a:r>
+            <a:endParaRPr lang="en-US" sz="1080" dirty="0"/>
+          </a:p>
+        </p:txBody>
+      </p:sp>
+      <p:sp>
+        <p:nvSpPr>
+          <p:cNvPr id="27" name="Shape 21"/>
           <p:cNvSpPr/>
           <p:nvPr/>
         </p:nvSpPr>
         <p:spPr>
           <a:xfrm>
-            <a:off x="777240" y="5742432"/>
-            <a:ext cx="2606040" cy="566928"/>
+            <a:off x="7946136" y="3749040"/>
+            <a:ext cx="3694176" cy="1691640"/>
           </a:xfrm>
           <a:prstGeom prst="roundRect">
             <a:avLst>
-              <a:gd name="adj" fmla="val 56452"/>
+              <a:gd name="adj" fmla="val 4324"/>
             </a:avLst>
           </a:prstGeom>
           <a:solidFill>
-            <a:srgbClr val="F2F2F3"/>
-          </a:solidFill>
-          <a:ln/>
-        </p:spPr>
-      </p:sp>
-      <p:sp>
-        <p:nvSpPr>
-          <p:cNvPr id="27" name="Text 21"/>
-          <p:cNvSpPr txBox="1"/>
-          <p:nvPr/>
-        </p:nvSpPr>
-        <p:spPr>
-          <a:xfrm>
-            <a:off x="941832" y="5742432"/>
-            <a:ext cx="365760" cy="566928"/>
-          </a:xfrm>
-          <a:prstGeom prst="rect">
-            <a:avLst/>
-          </a:prstGeom>
-          <a:noFill/>
-          <a:ln/>
-        </p:spPr>
-        <p:txBody>
-          <a:bodyPr wrap="square" lIns="0" tIns="0" rIns="0" bIns="0" rtlCol="0" anchor="ctr"/>
-          <a:lstStyle/>
-          <a:p>
-            <a:pPr algn="ctr" indent="0" marL="0">
-              <a:buNone/>
-            </a:pPr>
-            <a:r>
-              <a:rPr lang="en-US" sz="1600" b="1" dirty="0">
-                <a:solidFill>
-                  <a:srgbClr val="808184"/>
-                </a:solidFill>
-                <a:latin typeface="Cambria" pitchFamily="34" charset="0"/>
-                <a:ea typeface="Cambria" pitchFamily="34" charset="-122"/>
-                <a:cs typeface="Cambria" pitchFamily="34" charset="-120"/>
-              </a:rPr>
-              <a:t>1</a:t>
-            </a:r>
-            <a:endParaRPr lang="en-US" sz="1600" dirty="0"/>
-          </a:p>
-        </p:txBody>
-      </p:sp>
-      <p:sp>
-        <p:nvSpPr>
-          <p:cNvPr id="28" name="Text 22"/>
-          <p:cNvSpPr txBox="1"/>
-          <p:nvPr/>
-        </p:nvSpPr>
-        <p:spPr>
-          <a:xfrm>
-            <a:off x="1280160" y="5742432"/>
-            <a:ext cx="1965960" cy="566928"/>
-          </a:xfrm>
-          <a:prstGeom prst="rect">
-            <a:avLst/>
-          </a:prstGeom>
-          <a:noFill/>
-          <a:ln/>
-        </p:spPr>
-        <p:txBody>
-          <a:bodyPr wrap="square" lIns="0" tIns="0" rIns="0" bIns="0" rtlCol="0" anchor="ctr"/>
-          <a:lstStyle/>
-          <a:p>
-            <a:pPr indent="0" marL="0">
-              <a:buNone/>
-            </a:pPr>
-            <a:r>
-              <a:rPr lang="en-US" sz="1300" b="1" dirty="0">
-                <a:solidFill>
-                  <a:srgbClr val="3A3A3C"/>
-                </a:solidFill>
-                <a:latin typeface="Calibri" pitchFamily="34" charset="0"/>
-                <a:ea typeface="Calibri" pitchFamily="34" charset="-122"/>
-                <a:cs typeface="Calibri" pitchFamily="34" charset="-120"/>
-              </a:rPr>
-              <a:t>Retrieve</a:t>
-            </a:r>
-            <a:endParaRPr lang="en-US" sz="1300" dirty="0"/>
-          </a:p>
-        </p:txBody>
-      </p:sp>
-      <p:sp>
-        <p:nvSpPr>
-          <p:cNvPr id="29" name="Text 23"/>
-          <p:cNvSpPr txBox="1"/>
-          <p:nvPr/>
-        </p:nvSpPr>
-        <p:spPr>
-          <a:xfrm>
-            <a:off x="3401568" y="5742432"/>
-            <a:ext cx="182880" cy="566928"/>
-          </a:xfrm>
-          <a:prstGeom prst="rect">
-            <a:avLst/>
-          </a:prstGeom>
-          <a:noFill/>
-          <a:ln/>
-        </p:spPr>
-        <p:txBody>
-          <a:bodyPr wrap="square" lIns="0" tIns="0" rIns="0" bIns="0" rtlCol="0" anchor="ctr"/>
-          <a:lstStyle/>
-          <a:p>
-            <a:pPr algn="ctr" indent="0" marL="0">
-              <a:buNone/>
-            </a:pPr>
-            <a:r>
-              <a:rPr lang="en-US" sz="1600" dirty="0">
-                <a:solidFill>
-                  <a:srgbClr val="808184"/>
-                </a:solidFill>
-                <a:latin typeface="Calibri" pitchFamily="34" charset="0"/>
-                <a:ea typeface="Calibri" pitchFamily="34" charset="-122"/>
-                <a:cs typeface="Calibri" pitchFamily="34" charset="-120"/>
-              </a:rPr>
-              <a:t>→</a:t>
-            </a:r>
-            <a:endParaRPr lang="en-US" sz="1600" dirty="0"/>
-          </a:p>
-        </p:txBody>
-      </p:sp>
-      <p:sp>
-        <p:nvSpPr>
-          <p:cNvPr id="30" name="Shape 24"/>
+            <a:srgbClr val="FFFFFF"/>
+          </a:solidFill>
+          <a:ln w="9525">
+            <a:solidFill>
+              <a:srgbClr val="E3E3E4"/>
+            </a:solidFill>
+            <a:prstDash val="solid"/>
+          </a:ln>
+          <a:effectLst>
+            <a:outerShdw sx="100000" sy="100000" kx="0" ky="0" algn="bl" rotWithShape="0" blurRad="127000" dist="38100" dir="5400000">
+              <a:srgbClr val="58595B">
+                <a:alpha val="18000"/>
+              </a:srgbClr>
+            </a:outerShdw>
+          </a:effectLst>
+        </p:spPr>
+      </p:sp>
+      <p:sp>
+        <p:nvSpPr>
+          <p:cNvPr id="28" name="Shape 22"/>
           <p:cNvSpPr/>
           <p:nvPr/>
         </p:nvSpPr>
         <p:spPr>
           <a:xfrm>
-            <a:off x="3584448" y="5742432"/>
-            <a:ext cx="2606040" cy="566928"/>
-          </a:xfrm>
-          <a:prstGeom prst="roundRect">
-            <a:avLst>
-              <a:gd name="adj" fmla="val 56452"/>
-            </a:avLst>
-          </a:prstGeom>
-          <a:solidFill>
-            <a:srgbClr val="F2F2F3"/>
-          </a:solidFill>
-          <a:ln/>
-        </p:spPr>
-      </p:sp>
-      <p:sp>
-        <p:nvSpPr>
-          <p:cNvPr id="31" name="Text 25"/>
-          <p:cNvSpPr txBox="1"/>
-          <p:nvPr/>
-        </p:nvSpPr>
-        <p:spPr>
-          <a:xfrm>
-            <a:off x="3749040" y="5742432"/>
-            <a:ext cx="365760" cy="566928"/>
-          </a:xfrm>
-          <a:prstGeom prst="rect">
-            <a:avLst/>
-          </a:prstGeom>
-          <a:noFill/>
-          <a:ln/>
-        </p:spPr>
-        <p:txBody>
-          <a:bodyPr wrap="square" lIns="0" tIns="0" rIns="0" bIns="0" rtlCol="0" anchor="ctr"/>
-          <a:lstStyle/>
-          <a:p>
-            <a:pPr algn="ctr" indent="0" marL="0">
-              <a:buNone/>
-            </a:pPr>
-            <a:r>
-              <a:rPr lang="en-US" sz="1600" b="1" dirty="0">
-                <a:solidFill>
-                  <a:srgbClr val="808184"/>
-                </a:solidFill>
-                <a:latin typeface="Cambria" pitchFamily="34" charset="0"/>
-                <a:ea typeface="Cambria" pitchFamily="34" charset="-122"/>
-                <a:cs typeface="Cambria" pitchFamily="34" charset="-120"/>
-              </a:rPr>
-              <a:t>2</a:t>
-            </a:r>
-            <a:endParaRPr lang="en-US" sz="1600" dirty="0"/>
-          </a:p>
-        </p:txBody>
-      </p:sp>
-      <p:sp>
-        <p:nvSpPr>
-          <p:cNvPr id="32" name="Text 26"/>
-          <p:cNvSpPr txBox="1"/>
-          <p:nvPr/>
-        </p:nvSpPr>
-        <p:spPr>
-          <a:xfrm>
-            <a:off x="4087368" y="5742432"/>
-            <a:ext cx="1965960" cy="566928"/>
-          </a:xfrm>
-          <a:prstGeom prst="rect">
-            <a:avLst/>
-          </a:prstGeom>
-          <a:noFill/>
-          <a:ln/>
-        </p:spPr>
-        <p:txBody>
-          <a:bodyPr wrap="square" lIns="0" tIns="0" rIns="0" bIns="0" rtlCol="0" anchor="ctr"/>
-          <a:lstStyle/>
-          <a:p>
-            <a:pPr indent="0" marL="0">
-              <a:buNone/>
-            </a:pPr>
-            <a:r>
-              <a:rPr lang="en-US" sz="1300" b="1" dirty="0">
-                <a:solidFill>
-                  <a:srgbClr val="3A3A3C"/>
-                </a:solidFill>
-                <a:latin typeface="Calibri" pitchFamily="34" charset="0"/>
-                <a:ea typeface="Calibri" pitchFamily="34" charset="-122"/>
-                <a:cs typeface="Calibri" pitchFamily="34" charset="-120"/>
-              </a:rPr>
-              <a:t>Ground</a:t>
-            </a:r>
-            <a:endParaRPr lang="en-US" sz="1300" dirty="0"/>
-          </a:p>
-        </p:txBody>
-      </p:sp>
-      <p:sp>
-        <p:nvSpPr>
-          <p:cNvPr id="33" name="Text 27"/>
-          <p:cNvSpPr txBox="1"/>
-          <p:nvPr/>
-        </p:nvSpPr>
-        <p:spPr>
-          <a:xfrm>
-            <a:off x="6208776" y="5742432"/>
-            <a:ext cx="182880" cy="566928"/>
-          </a:xfrm>
-          <a:prstGeom prst="rect">
-            <a:avLst/>
-          </a:prstGeom>
-          <a:noFill/>
-          <a:ln/>
-        </p:spPr>
-        <p:txBody>
-          <a:bodyPr wrap="square" lIns="0" tIns="0" rIns="0" bIns="0" rtlCol="0" anchor="ctr"/>
-          <a:lstStyle/>
-          <a:p>
-            <a:pPr algn="ctr" indent="0" marL="0">
-              <a:buNone/>
-            </a:pPr>
-            <a:r>
-              <a:rPr lang="en-US" sz="1600" dirty="0">
-                <a:solidFill>
-                  <a:srgbClr val="808184"/>
-                </a:solidFill>
-                <a:latin typeface="Calibri" pitchFamily="34" charset="0"/>
-                <a:ea typeface="Calibri" pitchFamily="34" charset="-122"/>
-                <a:cs typeface="Calibri" pitchFamily="34" charset="-120"/>
-              </a:rPr>
-              <a:t>→</a:t>
-            </a:r>
-            <a:endParaRPr lang="en-US" sz="1600" dirty="0"/>
-          </a:p>
-        </p:txBody>
-      </p:sp>
-      <p:sp>
-        <p:nvSpPr>
-          <p:cNvPr id="34" name="Shape 28"/>
-          <p:cNvSpPr/>
-          <p:nvPr/>
-        </p:nvSpPr>
-        <p:spPr>
-          <a:xfrm>
-            <a:off x="6391656" y="5742432"/>
-            <a:ext cx="2606040" cy="566928"/>
-          </a:xfrm>
-          <a:prstGeom prst="roundRect">
-            <a:avLst>
-              <a:gd name="adj" fmla="val 56452"/>
-            </a:avLst>
-          </a:prstGeom>
-          <a:solidFill>
-            <a:srgbClr val="F2F2F3"/>
-          </a:solidFill>
-          <a:ln/>
-        </p:spPr>
-      </p:sp>
-      <p:sp>
-        <p:nvSpPr>
-          <p:cNvPr id="35" name="Text 29"/>
-          <p:cNvSpPr txBox="1"/>
-          <p:nvPr/>
-        </p:nvSpPr>
-        <p:spPr>
-          <a:xfrm>
-            <a:off x="6556248" y="5742432"/>
-            <a:ext cx="365760" cy="566928"/>
-          </a:xfrm>
-          <a:prstGeom prst="rect">
-            <a:avLst/>
-          </a:prstGeom>
-          <a:noFill/>
-          <a:ln/>
-        </p:spPr>
-        <p:txBody>
-          <a:bodyPr wrap="square" lIns="0" tIns="0" rIns="0" bIns="0" rtlCol="0" anchor="ctr"/>
-          <a:lstStyle/>
-          <a:p>
-            <a:pPr algn="ctr" indent="0" marL="0">
-              <a:buNone/>
-            </a:pPr>
-            <a:r>
-              <a:rPr lang="en-US" sz="1600" b="1" dirty="0">
-                <a:solidFill>
-                  <a:srgbClr val="808184"/>
-                </a:solidFill>
-                <a:latin typeface="Cambria" pitchFamily="34" charset="0"/>
-                <a:ea typeface="Cambria" pitchFamily="34" charset="-122"/>
-                <a:cs typeface="Cambria" pitchFamily="34" charset="-120"/>
-              </a:rPr>
-              <a:t>3</a:t>
-            </a:r>
-            <a:endParaRPr lang="en-US" sz="1600" dirty="0"/>
-          </a:p>
-        </p:txBody>
-      </p:sp>
-      <p:sp>
-        <p:nvSpPr>
-          <p:cNvPr id="36" name="Text 30"/>
-          <p:cNvSpPr txBox="1"/>
-          <p:nvPr/>
-        </p:nvSpPr>
-        <p:spPr>
-          <a:xfrm>
-            <a:off x="6894576" y="5742432"/>
-            <a:ext cx="1965960" cy="566928"/>
-          </a:xfrm>
-          <a:prstGeom prst="rect">
-            <a:avLst/>
-          </a:prstGeom>
-          <a:noFill/>
-          <a:ln/>
-        </p:spPr>
-        <p:txBody>
-          <a:bodyPr wrap="square" lIns="0" tIns="0" rIns="0" bIns="0" rtlCol="0" anchor="ctr"/>
-          <a:lstStyle/>
-          <a:p>
-            <a:pPr indent="0" marL="0">
-              <a:buNone/>
-            </a:pPr>
-            <a:r>
-              <a:rPr lang="en-US" sz="1300" b="1" dirty="0">
-                <a:solidFill>
-                  <a:srgbClr val="3A3A3C"/>
-                </a:solidFill>
-                <a:latin typeface="Calibri" pitchFamily="34" charset="0"/>
-                <a:ea typeface="Calibri" pitchFamily="34" charset="-122"/>
-                <a:cs typeface="Calibri" pitchFamily="34" charset="-120"/>
-              </a:rPr>
-              <a:t>Generate</a:t>
-            </a:r>
-            <a:endParaRPr lang="en-US" sz="1300" dirty="0"/>
-          </a:p>
-        </p:txBody>
-      </p:sp>
-      <p:sp>
-        <p:nvSpPr>
-          <p:cNvPr id="37" name="Text 31"/>
-          <p:cNvSpPr txBox="1"/>
-          <p:nvPr/>
-        </p:nvSpPr>
-        <p:spPr>
-          <a:xfrm>
-            <a:off x="9015984" y="5742432"/>
-            <a:ext cx="182880" cy="566928"/>
-          </a:xfrm>
-          <a:prstGeom prst="rect">
-            <a:avLst/>
-          </a:prstGeom>
-          <a:noFill/>
-          <a:ln/>
-        </p:spPr>
-        <p:txBody>
-          <a:bodyPr wrap="square" lIns="0" tIns="0" rIns="0" bIns="0" rtlCol="0" anchor="ctr"/>
-          <a:lstStyle/>
-          <a:p>
-            <a:pPr algn="ctr" indent="0" marL="0">
-              <a:buNone/>
-            </a:pPr>
-            <a:r>
-              <a:rPr lang="en-US" sz="1600" dirty="0">
-                <a:solidFill>
-                  <a:srgbClr val="808184"/>
-                </a:solidFill>
-                <a:latin typeface="Calibri" pitchFamily="34" charset="0"/>
-                <a:ea typeface="Calibri" pitchFamily="34" charset="-122"/>
-                <a:cs typeface="Calibri" pitchFamily="34" charset="-120"/>
-              </a:rPr>
-              <a:t>→</a:t>
-            </a:r>
-            <a:endParaRPr lang="en-US" sz="1600" dirty="0"/>
-          </a:p>
-        </p:txBody>
-      </p:sp>
-      <p:sp>
-        <p:nvSpPr>
-          <p:cNvPr id="38" name="Shape 32"/>
-          <p:cNvSpPr/>
-          <p:nvPr/>
-        </p:nvSpPr>
-        <p:spPr>
-          <a:xfrm>
-            <a:off x="9198864" y="5742432"/>
-            <a:ext cx="2606040" cy="566928"/>
-          </a:xfrm>
-          <a:prstGeom prst="roundRect">
-            <a:avLst>
-              <a:gd name="adj" fmla="val 56452"/>
-            </a:avLst>
-          </a:prstGeom>
-          <a:solidFill>
-            <a:srgbClr val="FDEEDA"/>
-          </a:solidFill>
-          <a:ln/>
-        </p:spPr>
-      </p:sp>
-      <p:sp>
-        <p:nvSpPr>
-          <p:cNvPr id="39" name="Text 33"/>
-          <p:cNvSpPr txBox="1"/>
-          <p:nvPr/>
-        </p:nvSpPr>
-        <p:spPr>
-          <a:xfrm>
-            <a:off x="9363456" y="5742432"/>
-            <a:ext cx="365760" cy="566928"/>
-          </a:xfrm>
-          <a:prstGeom prst="rect">
-            <a:avLst/>
-          </a:prstGeom>
-          <a:noFill/>
-          <a:ln/>
-        </p:spPr>
-        <p:txBody>
-          <a:bodyPr wrap="square" lIns="0" tIns="0" rIns="0" bIns="0" rtlCol="0" anchor="ctr"/>
-          <a:lstStyle/>
-          <a:p>
-            <a:pPr algn="ctr" indent="0" marL="0">
-              <a:buNone/>
-            </a:pPr>
-            <a:r>
-              <a:rPr lang="en-US" sz="1600" b="1" dirty="0">
-                <a:solidFill>
-                  <a:srgbClr val="E07B00"/>
-                </a:solidFill>
-                <a:latin typeface="Cambria" pitchFamily="34" charset="0"/>
-                <a:ea typeface="Cambria" pitchFamily="34" charset="-122"/>
-                <a:cs typeface="Cambria" pitchFamily="34" charset="-120"/>
-              </a:rPr>
-              <a:t>4</a:t>
-            </a:r>
-            <a:endParaRPr lang="en-US" sz="1600" dirty="0"/>
-          </a:p>
-        </p:txBody>
-      </p:sp>
-      <p:sp>
-        <p:nvSpPr>
-          <p:cNvPr id="40" name="Text 34"/>
-          <p:cNvSpPr txBox="1"/>
-          <p:nvPr/>
-        </p:nvSpPr>
-        <p:spPr>
-          <a:xfrm>
-            <a:off x="9701784" y="5742432"/>
-            <a:ext cx="1965960" cy="566928"/>
-          </a:xfrm>
-          <a:prstGeom prst="rect">
-            <a:avLst/>
-          </a:prstGeom>
-          <a:noFill/>
-          <a:ln/>
-        </p:spPr>
-        <p:txBody>
-          <a:bodyPr wrap="square" lIns="0" tIns="0" rIns="0" bIns="0" rtlCol="0" anchor="ctr"/>
-          <a:lstStyle/>
-          <a:p>
-            <a:pPr indent="0" marL="0">
-              <a:buNone/>
-            </a:pPr>
-            <a:r>
-              <a:rPr lang="en-US" sz="1300" b="1" dirty="0">
-                <a:solidFill>
-                  <a:srgbClr val="3A3A3C"/>
-                </a:solidFill>
-                <a:latin typeface="Calibri" pitchFamily="34" charset="0"/>
-                <a:ea typeface="Calibri" pitchFamily="34" charset="-122"/>
-                <a:cs typeface="Calibri" pitchFamily="34" charset="-120"/>
-              </a:rPr>
-              <a:t>Human review</a:t>
-            </a:r>
-            <a:endParaRPr lang="en-US" sz="1300" dirty="0"/>
-          </a:p>
-        </p:txBody>
+            <a:off x="8147304" y="3950208"/>
+            <a:ext cx="457200" cy="457200"/>
+          </a:xfrm>
+          <a:prstGeom prst="ellipse">
+            <a:avLst/>
+          </a:prstGeom>
+          <a:solidFill>
+            <a:srgbClr val="58595B"/>
+          </a:solidFill>
+          <a:ln/>
+        </p:spPr>
       </p:sp>
       <p:pic>
         <p:nvPicPr>
-          <p:cNvPr id="41" name="Image 4" descr="/tmp/pptx_assets/poweract_logo.png">    </p:cNvPr>
+          <p:cNvPr id="29" name="Image 4" descr="/tmp/pptx_assets/icon_exec_narrative.png">    </p:cNvPr>
           <p:cNvPicPr>
             <a:picLocks noChangeAspect="1"/>
           </p:cNvPicPr>
@@ -3061,8 +2663,8 @@
         </p:blipFill>
         <p:spPr>
           <a:xfrm>
-            <a:off x="457200" y="6473952"/>
-            <a:ext cx="822960" cy="265176"/>
+            <a:off x="8257032" y="4059936"/>
+            <a:ext cx="237744" cy="237744"/>
           </a:xfrm>
           <a:prstGeom prst="rect">
             <a:avLst/>
@@ -3071,14 +2673,14 @@
       </p:pic>
       <p:sp>
         <p:nvSpPr>
-          <p:cNvPr id="42" name="Text 35"/>
-          <p:cNvSpPr txBox="1"/>
-          <p:nvPr/>
-        </p:nvSpPr>
-        <p:spPr>
-          <a:xfrm>
-            <a:off x="1463040" y="6492240"/>
-            <a:ext cx="7315200" cy="274320"/>
+          <p:cNvPr id="30" name="Text 23"/>
+          <p:cNvSpPr txBox="1"/>
+          <p:nvPr/>
+        </p:nvSpPr>
+        <p:spPr>
+          <a:xfrm>
+            <a:off x="8723376" y="3931920"/>
+            <a:ext cx="2734056" cy="502920"/>
           </a:xfrm>
           <a:prstGeom prst="rect">
             <a:avLst/>
@@ -3094,15 +2696,120 @@
               <a:buNone/>
             </a:pPr>
             <a:r>
-              <a:rPr lang="en-US" sz="900" dirty="0">
-                <a:solidFill>
-                  <a:srgbClr val="808184"/>
+              <a:rPr lang="en-US" sz="1400" b="1" dirty="0">
+                <a:solidFill>
+                  <a:srgbClr val="3A3A3C"/>
+                </a:solidFill>
+                <a:latin typeface="Cambria" pitchFamily="34" charset="0"/>
+                <a:ea typeface="Cambria" pitchFamily="34" charset="-122"/>
+                <a:cs typeface="Cambria" pitchFamily="34" charset="-120"/>
+              </a:rPr>
+              <a:t>Report up in plain English</a:t>
+            </a:r>
+            <a:endParaRPr lang="en-US" sz="1400" dirty="0"/>
+          </a:p>
+        </p:txBody>
+      </p:sp>
+      <p:sp>
+        <p:nvSpPr>
+          <p:cNvPr id="31" name="Text 24"/>
+          <p:cNvSpPr txBox="1"/>
+          <p:nvPr/>
+        </p:nvSpPr>
+        <p:spPr>
+          <a:xfrm>
+            <a:off x="8147304" y="4526280"/>
+            <a:ext cx="3291840" cy="795528"/>
+          </a:xfrm>
+          <a:prstGeom prst="rect">
+            <a:avLst/>
+          </a:prstGeom>
+          <a:noFill/>
+          <a:ln/>
+        </p:spPr>
+        <p:txBody>
+          <a:bodyPr wrap="square" lIns="0" tIns="0" rIns="0" bIns="0" rtlCol="0" anchor="ctr"/>
+          <a:lstStyle/>
+          <a:p>
+            <a:pPr indent="0" marL="0">
+              <a:lnSpc>
+                <a:spcPct val="112000"/>
+              </a:lnSpc>
+              <a:buNone/>
+            </a:pPr>
+            <a:r>
+              <a:rPr lang="en-US" sz="1080" dirty="0">
+                <a:solidFill>
+                  <a:srgbClr val="58595B"/>
                 </a:solidFill>
                 <a:latin typeface="Calibri" pitchFamily="34" charset="0"/>
                 <a:ea typeface="Calibri" pitchFamily="34" charset="-122"/>
                 <a:cs typeface="Calibri" pitchFamily="34" charset="-120"/>
               </a:rPr>
-              <a:t>AI Capabilities</a:t>
+              <a:t>Turns raw ADKAR scores into a short, readable narrative a sponsor can absorb in under a minute.</a:t>
+            </a:r>
+            <a:endParaRPr lang="en-US" sz="1080" dirty="0"/>
+          </a:p>
+        </p:txBody>
+      </p:sp>
+      <p:pic>
+        <p:nvPicPr>
+          <p:cNvPr id="32" name="Image 5" descr="/tmp/pptx_assets/poweract_logo.png">    </p:cNvPr>
+          <p:cNvPicPr>
+            <a:picLocks noChangeAspect="1"/>
+          </p:cNvPicPr>
+          <p:nvPr/>
+        </p:nvPicPr>
+        <p:blipFill>
+          <a:blip r:embed="rId6"/>
+          <a:stretch>
+            <a:fillRect/>
+          </a:stretch>
+        </p:blipFill>
+        <p:spPr>
+          <a:xfrm>
+            <a:off x="457200" y="6473952"/>
+            <a:ext cx="822960" cy="265176"/>
+          </a:xfrm>
+          <a:prstGeom prst="rect">
+            <a:avLst/>
+          </a:prstGeom>
+        </p:spPr>
+      </p:pic>
+      <p:sp>
+        <p:nvSpPr>
+          <p:cNvPr id="33" name="Text 25"/>
+          <p:cNvSpPr txBox="1"/>
+          <p:nvPr/>
+        </p:nvSpPr>
+        <p:spPr>
+          <a:xfrm>
+            <a:off x="1463040" y="6492240"/>
+            <a:ext cx="7315200" cy="274320"/>
+          </a:xfrm>
+          <a:prstGeom prst="rect">
+            <a:avLst/>
+          </a:prstGeom>
+          <a:noFill/>
+          <a:ln/>
+        </p:spPr>
+        <p:txBody>
+          <a:bodyPr wrap="square" lIns="0" tIns="0" rIns="0" bIns="0" rtlCol="0" anchor="ctr"/>
+          <a:lstStyle/>
+          <a:p>
+            <a:pPr indent="0" marL="0">
+              <a:buNone/>
+            </a:pPr>
+            <a:r>
+              <a:rPr lang="en-US" sz="900" dirty="0">
+                <a:solidFill>
+                  <a:srgbClr val="808184"/>
+                </a:solidFill>
+                <a:latin typeface="Calibri" pitchFamily="34" charset="0"/>
+                <a:ea typeface="Calibri" pitchFamily="34" charset="-122"/>
+                <a:cs typeface="Calibri" pitchFamily="34" charset="-120"/>
+              </a:rPr>
+              <a:t>AI Use Cases</a:t>
             </a:r>
             <a:endParaRPr lang="en-US" sz="900" dirty="0"/>
           </a:p>
@@ -3110,7 +2817,7 @@
       </p:sp>
       <p:sp>
         <p:nvSpPr>
-          <p:cNvPr id="43" name="Text 36"/>
+          <p:cNvPr id="34" name="Text 26"/>
           <p:cNvSpPr txBox="1"/>
           <p:nvPr/>
         </p:nvSpPr>

</xml_diff>